<commit_message>
docs(ia): informe y presentación con la IA gratuita y las funciones nuevas
- Informe, sección 10: Gemini gratuito (y su advertencia de datos), RF-17
  a RF-19, reglas R-14 y R-15, material de prueba, pruebas (11, 24 y 29) y
  figuras 28 a 32 con la interfaz nueva.
- Presentación: «La IA en la plataforma» (revisión al subir, Tutor IA,
  simulacro y vista previa), evidencia con la interfaz nueva y pruebas
  actualizadas.

Co-Authored-By: Claude Opus 5.5 <noreply@anthropic.com>
</commit_message>
<xml_diff>
--- a/docs/ia/Presentacion_con_Tutor_IA.pptx
+++ b/docs/ia/Presentacion_con_Tutor_IA.pptx
@@ -10748,7 +10748,7 @@
           <a:p>
             <a:r>
               <a:rPr lang="en-US"/>
-              <a:t>Tutor IA</a:t>
+              <a:t>IA gratuita</a:t>
             </a:r>
             <a:endParaRPr lang="en-US" sz="4800"/>
           </a:p>
@@ -10784,7 +10784,7 @@
                   <a:schemeClr val="accent6"/>
                 </a:solidFill>
               </a:rPr>
-              <a:t>Un tutor con inteligencia artificial que explica cada material, genera quices de práctica y resuelve dudas. Se agregó después de estas pruebas, a pedido del docente.</a:t>
+              <a:t>IA gratuita (Google Gemini) que revisa cada archivo antes de publicarlo, explica el material, genera quices y arma simulacros de parcial. Se agregó después de estas pruebas, a pedido del docente.</a:t>
             </a:r>
             <a:endParaRPr lang="en-US" sz="2200" dirty="0"/>
           </a:p>
@@ -10873,7 +10873,7 @@
                   <a:schemeClr val="tx1"/>
                 </a:solidFill>
               </a:rPr>
-              <a:t>Tutor IA: qué hace</a:t>
+              <a:t>La IA en la plataforma</a:t>
             </a:r>
             <a:endParaRPr lang="en-US" sz="3200" dirty="0"/>
           </a:p>
@@ -10964,7 +10964,7 @@
                 <a:ea typeface="Courier New" pitchFamily="34" charset="-122"/>
                 <a:cs typeface="Courier New" pitchFamily="34" charset="-120"/>
               </a:rPr>
-              <a:t>EXP</a:t>
+              <a:t>REV</a:t>
             </a:r>
             <a:endParaRPr lang="en-US" sz="1300" dirty="0"/>
           </a:p>
@@ -11000,7 +11000,7 @@
                   <a:schemeClr val="tx1"/>
                 </a:solidFill>
               </a:rPr>
-              <a:t>Explicación (RF-14)</a:t>
+              <a:t>Revisión al subir (RF-17)</a:t>
             </a:r>
             <a:endParaRPr lang="en-US" sz="1800" dirty="0"/>
           </a:p>
@@ -11036,7 +11036,7 @@
                   <a:schemeClr val="tx2"/>
                 </a:solidFill>
               </a:rPr>
-              <a:t>Resumen, temas explicados y ejercicios con pista y solución ocultas</a:t>
+              <a:t>Solo publica material académico de la asignatura; rechaza lo demás con el motivo</a:t>
             </a:r>
             <a:endParaRPr lang="en-US" sz="1400" dirty="0"/>
           </a:p>
@@ -11127,7 +11127,7 @@
                 <a:ea typeface="Courier New" pitchFamily="34" charset="-122"/>
                 <a:cs typeface="Courier New" pitchFamily="34" charset="-120"/>
               </a:rPr>
-              <a:t>QUIZ</a:t>
+              <a:t>IA</a:t>
             </a:r>
             <a:endParaRPr lang="en-US" sz="1300" dirty="0"/>
           </a:p>
@@ -11163,7 +11163,7 @@
                   <a:schemeClr val="tx1"/>
                 </a:solidFill>
               </a:rPr>
-              <a:t>Práctica (RF-15)</a:t>
+              <a:t>Tutor IA (RF-14 a RF-16)</a:t>
             </a:r>
             <a:endParaRPr lang="en-US" sz="1800" dirty="0"/>
           </a:p>
@@ -11199,7 +11199,7 @@
                   <a:schemeClr val="tx2"/>
                 </a:solidFill>
               </a:rPr>
-              <a:t>Quiz de 5 preguntas de opción múltiple con retroalimentación</a:t>
+              <a:t>Explica el material, genera un quiz y resuelve dudas en un chat</a:t>
             </a:r>
             <a:endParaRPr lang="en-US" sz="1400" dirty="0"/>
           </a:p>
@@ -11290,7 +11290,7 @@
                 <a:ea typeface="Courier New" pitchFamily="34" charset="-122"/>
                 <a:cs typeface="Courier New" pitchFamily="34" charset="-120"/>
               </a:rPr>
-              <a:t>CHAT</a:t>
+              <a:t>SIM</a:t>
             </a:r>
             <a:endParaRPr lang="en-US" sz="1300" dirty="0"/>
           </a:p>
@@ -11326,7 +11326,7 @@
                   <a:schemeClr val="tx1"/>
                 </a:solidFill>
               </a:rPr>
-              <a:t>Preguntas al tutor (RF-16)</a:t>
+              <a:t>Simulacro de parcial (RF-18)</a:t>
             </a:r>
             <a:endParaRPr lang="en-US" sz="1800" dirty="0"/>
           </a:p>
@@ -11362,7 +11362,7 @@
                   <a:schemeClr val="tx2"/>
                 </a:solidFill>
               </a:rPr>
-              <a:t>Chat sobre el material que tiene en cuenta la conversación</a:t>
+              <a:t>Examen de práctica por asignatura, con nota y temas para repasar</a:t>
             </a:r>
             <a:endParaRPr lang="en-US" sz="1400" dirty="0"/>
           </a:p>
@@ -11453,7 +11453,7 @@
                 <a:ea typeface="Courier New" pitchFamily="34" charset="-122"/>
                 <a:cs typeface="Courier New" pitchFamily="34" charset="-120"/>
               </a:rPr>
-              <a:t>USO</a:t>
+              <a:t>VER</a:t>
             </a:r>
             <a:endParaRPr lang="en-US" sz="1300" dirty="0"/>
           </a:p>
@@ -11489,7 +11489,7 @@
                   <a:schemeClr val="tx1"/>
                 </a:solidFill>
               </a:rPr>
-              <a:t>Uso responsable (RNF-08)</a:t>
+              <a:t>Vista previa (RF-19)</a:t>
             </a:r>
             <a:endParaRPr lang="en-US" sz="1800" dirty="0"/>
           </a:p>
@@ -11525,7 +11525,7 @@
                   <a:schemeClr val="tx2"/>
                 </a:solidFill>
               </a:rPr>
-              <a:t>Aviso «Generado con IA» y el chat no se guarda en el servidor (R-11)</a:t>
+              <a:t>Primera página del PDF o la imagen en cada tarjeta y en la ficha</a:t>
             </a:r>
             <a:endParaRPr lang="en-US" sz="1400" dirty="0"/>
           </a:p>
@@ -11569,7 +11569,7 @@
                   <a:schemeClr val="tx1"/>
                 </a:solidFill>
               </a:rPr>
-              <a:t>el backend envía el PDF o la imagen del material a Claude Opus 5.5 (Anthropic), que lo lee y responde en español. </a:t>
+              <a:t>el backend envía el PDF o la imagen a Google Gemini (nivel gratuito, gemini-3.8-flash), que lo lee y responde en español. </a:t>
             </a:r>
             <a:r>
               <a:rPr lang="en-US" sz="1500" b="1" dirty="0">
@@ -11585,7 +11585,7 @@
                   <a:schemeClr val="tx1"/>
                 </a:solidFill>
               </a:rPr>
-              <a:t>en la ficha de cada material, panel «Tutor IA».</a:t>
+              <a:t>al subir material, en la ficha de cada material y en «Simulacro IA».</a:t>
             </a:r>
             <a:endParaRPr lang="en-US" sz="1500" dirty="0"/>
           </a:p>
@@ -12397,7 +12397,7 @@
                   <a:schemeClr val="tx1"/>
                 </a:solidFill>
               </a:rPr>
-              <a:t>Evidencia: el Tutor IA y la identidad UTB</a:t>
+              <a:t>Evidencia: la nueva interfaz con IA</a:t>
             </a:r>
             <a:endParaRPr lang="en-US" sz="3200" dirty="0"/>
           </a:p>
@@ -12484,7 +12484,7 @@
                   <a:schemeClr val="tx2"/>
                 </a:solidFill>
               </a:rPr>
-              <a:t>Fig. 28 · Pantalla principal con los colores y el logo de la UTB y el banner del Tutor IA. RF-03, RF-04</a:t>
+              <a:t>Fig. 28 · Explorar: cada material con su vista previa. RF-03, RF-04, RF-19</a:t>
             </a:r>
             <a:endParaRPr lang="en-US" sz="1100" dirty="0"/>
           </a:p>
@@ -12571,7 +12571,7 @@
                   <a:schemeClr val="tx2"/>
                 </a:solidFill>
               </a:rPr>
-              <a:t>Fig. 29 · Ficha del material con el panel Tutor IA. RF-14 a RF-16</a:t>
+              <a:t>Fig. 29 · Inicio con barra lateral y las funciones de IA. RF-18</a:t>
             </a:r>
             <a:endParaRPr lang="en-US" sz="1100" dirty="0"/>
           </a:p>
@@ -12658,7 +12658,7 @@
                   <a:schemeClr val="tx2"/>
                 </a:solidFill>
               </a:rPr>
-              <a:t>Fig. 30 · Inicio de sesión con el panel institucional de la UTB. RF-02</a:t>
+              <a:t>Fig. 30 · Subir material: la IA lo revisa antes de publicarlo. RF-17</a:t>
             </a:r>
             <a:endParaRPr lang="en-US" sz="1100" dirty="0"/>
           </a:p>
@@ -12901,7 +12901,7 @@
                   <a:schemeClr val="tx2"/>
                 </a:solidFill>
               </a:rPr>
-              <a:t>Pulsa «Explicar este material» o «Generar quiz», o escribe una pregunta en la ficha.</a:t>
+              <a:t>Sube un archivo, pide una explicación o un quiz, pregunta o genera un simulacro.</a:t>
             </a:r>
             <a:endParaRPr lang="en-US" sz="1500" dirty="0"/>
           </a:p>
@@ -13034,7 +13034,7 @@
                   <a:schemeClr val="tx2"/>
                 </a:solidFill>
               </a:rPr>
-              <a:t>Si el material ya tiene explicación o quiz, lo devuelve al instante y sin costo (R-10).</a:t>
+              <a:t>Si ya hay una explicación o un quiz guardado, lo devuelve sin gastar cuota (R-10).</a:t>
             </a:r>
             <a:endParaRPr lang="en-US" sz="1500" dirty="0"/>
           </a:p>
@@ -13131,7 +13131,7 @@
                   <a:schemeClr val="tx1"/>
                 </a:solidFill>
               </a:rPr>
-              <a:t>Claude lee el material</a:t>
+              <a:t>Gemini lee el material</a:t>
             </a:r>
             <a:endParaRPr lang="en-US" sz="1900" dirty="0"/>
           </a:p>
@@ -13167,7 +13167,7 @@
                   <a:schemeClr val="tx2"/>
                 </a:solidFill>
               </a:rPr>
-              <a:t>Recibe el PDF o la imagen con las instrucciones del tutor (R-12, R-13).</a:t>
+              <a:t>Recibe el PDF o la imagen con instrucciones de tutor o de revisor (R-12, R-13).</a:t>
             </a:r>
             <a:endParaRPr lang="en-US" sz="1500" dirty="0"/>
           </a:p>
@@ -13300,7 +13300,7 @@
                   <a:schemeClr val="tx2"/>
                 </a:solidFill>
               </a:rPr>
-              <a:t>Un esquema JSON permite mostrar tarjetas, pistas y quices en la app.</a:t>
+              <a:t>Un esquema JSON fijo; en la revisión, el servidor decide el veredicto (R-14).</a:t>
             </a:r>
             <a:endParaRPr lang="en-US" sz="1500" dirty="0"/>
           </a:p>
@@ -14250,7 +14250,7 @@
                   <a:schemeClr val="tx1"/>
                 </a:solidFill>
               </a:rPr>
-              <a:t>De Word y ZIP, la IA solo recibe el título y la descripción.</a:t>
+              <a:t>De los ZIP y archivos de más de 20 MB, la IA solo recibe el título.</a:t>
             </a:r>
             <a:endParaRPr lang="en-US" sz="1400" dirty="0"/>
           </a:p>
@@ -14297,7 +14297,7 @@
                   <a:schemeClr val="tx2"/>
                 </a:solidFill>
               </a:rPr>
-              <a:t>El modelo lee PDF e imágenes de hasta 32 MB</a:t>
+              <a:t>El modelo lee PDF, imágenes y el texto de los Word</a:t>
             </a:r>
             <a:endParaRPr lang="en-US" sz="1300" dirty="0"/>
           </a:p>
@@ -14601,7 +14601,7 @@
                   <a:schemeClr val="tx2"/>
                 </a:solidFill>
               </a:rPr>
-              <a:t>Controlar el costo de la API</a:t>
+              <a:t>No agotar la cuota gratuita de la IA</a:t>
             </a:r>
             <a:endParaRPr lang="en-US" sz="1300" dirty="0"/>
           </a:p>
@@ -14662,7 +14662,7 @@
                   <a:schemeClr val="tx1"/>
                 </a:solidFill>
               </a:rPr>
-              <a:t>Las cuatro reglas ya funcionan en el código; falta que el equipo las apruebe y las agregue a la sección 6.3.</a:t>
+              <a:t>También R-14 (el servidor decide el veredicto de la revisión) y R-15 (lo pendiente solo lo ven su autor y el administrador). Falta aprobarlas.</a:t>
             </a:r>
             <a:endParaRPr lang="en-US" sz="1500" dirty="0"/>
           </a:p>
@@ -15018,7 +15018,7 @@
                 <a:ea typeface="Cambria" pitchFamily="34" charset="-122"/>
                 <a:cs typeface="Cambria" pitchFamily="34" charset="-120"/>
               </a:rPr>
-              <a:t>20 / 20</a:t>
+              <a:t>24 / 24</a:t>
             </a:r>
             <a:endParaRPr lang="en-US" sz="4000" dirty="0"/>
           </a:p>
@@ -15054,7 +15054,7 @@
                   <a:schemeClr val="tx2"/>
                 </a:solidFill>
               </a:rPr>
-              <a:t>API contra PostgreSQL 16 con una IA simulada: RF-01 a RF-16</a:t>
+              <a:t>Con una IA simulada: RF-01 a RF-19 y la revisión al subir</a:t>
             </a:r>
             <a:endParaRPr lang="en-US" sz="1400" dirty="0"/>
           </a:p>
@@ -15159,7 +15159,7 @@
                 <a:ea typeface="Cambria" pitchFamily="34" charset="-122"/>
                 <a:cs typeface="Cambria" pitchFamily="34" charset="-120"/>
               </a:rPr>
-              <a:t>24 / 24</a:t>
+              <a:t>29 / 29</a:t>
             </a:r>
             <a:endParaRPr lang="en-US" sz="4000" dirty="0"/>
           </a:p>
@@ -15195,7 +15195,7 @@
                   <a:schemeClr val="tx2"/>
                 </a:solidFill>
               </a:rPr>
-              <a:t>Widgets: explicación, quiz, chat y ficha a 360 px</a:t>
+              <a:t>Widgets: revisión al subir, quiz, simulacro y celular</a:t>
             </a:r>
             <a:endParaRPr lang="en-US" sz="1400" dirty="0"/>
           </a:p>

</xml_diff>